<commit_message>
feat: static thumbnails for template previews (professional approach)
</commit_message>
<xml_diff>
--- a/public/templates/modern.pptx
+++ b/public/templates/modern.pptx
@@ -5,25 +5,20 @@
     <p:sldMasterId id="2147483659" r:id="rId1"/>
   </p:sldMasterIdLst>
   <p:notesMasterIdLst>
-    <p:notesMasterId r:id="rId4"/>
+    <p:notesMasterId r:id="rId3"/>
   </p:notesMasterIdLst>
   <p:sldIdLst>
     <p:sldId id="273" r:id="rId2"/>
-    <p:sldId id="277" r:id="rId3"/>
   </p:sldIdLst>
   <p:sldSz cx="18288000" cy="10287000"/>
   <p:notesSz cx="6858000" cy="9144000"/>
   <p:embeddedFontLst>
     <p:embeddedFont>
       <p:font typeface="Calibri" pitchFamily="34" charset="0"/>
-      <p:regular r:id="rId5"/>
-      <p:bold r:id="rId6"/>
-      <p:italic r:id="rId7"/>
-      <p:boldItalic r:id="rId8"/>
-    </p:embeddedFont>
-    <p:embeddedFont>
-      <p:font typeface="Hammersmith One" charset="0"/>
-      <p:regular r:id="rId9"/>
+      <p:regular r:id="rId4"/>
+      <p:bold r:id="rId5"/>
+      <p:italic r:id="rId6"/>
+      <p:boldItalic r:id="rId7"/>
     </p:embeddedFont>
   </p:embeddedFontLst>
   <p:defaultTextStyle>
@@ -257,7 +252,7 @@
   </p:defaultTextStyle>
   <p:extLst>
     <p:ext uri="{EFAFB233-063F-42B5-8137-9DF3F51BA10A}">
-      <p15:sldGuideLst xmlns:ahyp="http://schemas.microsoft.com/office/drawing/2018/hyperlinkcolor" xmlns:p15="http://schemas.microsoft.com/office/powerpoint/2012/main" xmlns:p14="http://schemas.microsoft.com/office/powerpoint/2010/main" xmlns:com="http://schemas.openxmlformats.org/drawingml/2006/compatibility" xmlns:pvml="urn:schemas-microsoft-com:office:powerpoint" xmlns:v="urn:schemas-microsoft-com:vml" xmlns:o="urn:schemas-microsoft-com:office:office" xmlns:dgm="http://schemas.openxmlformats.org/drawingml/2006/diagram" xmlns:c="http://schemas.openxmlformats.org/drawingml/2006/chart" xmlns:mv="urn:schemas-microsoft-com:mac:vml" xmlns:mc="http://schemas.openxmlformats.org/markup-compatibility/2006" xmlns="">
+      <p15:sldGuideLst xmlns="" xmlns:mc="http://schemas.openxmlformats.org/markup-compatibility/2006" xmlns:mv="urn:schemas-microsoft-com:mac:vml" xmlns:c="http://schemas.openxmlformats.org/drawingml/2006/chart" xmlns:dgm="http://schemas.openxmlformats.org/drawingml/2006/diagram" xmlns:o="urn:schemas-microsoft-com:office:office" xmlns:v="urn:schemas-microsoft-com:vml" xmlns:pvml="urn:schemas-microsoft-com:office:powerpoint" xmlns:com="http://schemas.openxmlformats.org/drawingml/2006/compatibility" xmlns:p14="http://schemas.microsoft.com/office/powerpoint/2010/main" xmlns:p15="http://schemas.microsoft.com/office/powerpoint/2012/main" xmlns:ahyp="http://schemas.microsoft.com/office/drawing/2018/hyperlinkcolor">
         <p15:guide id="1" orient="horz" pos="2160">
           <p15:clr>
             <a:srgbClr val="A4A3A4"/>
@@ -773,110 +768,6 @@
       <p:sp>
         <p:nvSpPr>
           <p:cNvPr id="371" name="Google Shape;371;p18:notes"/>
-          <p:cNvSpPr>
-            <a:spLocks noGrp="1" noRot="1" noChangeAspect="1"/>
-          </p:cNvSpPr>
-          <p:nvPr>
-            <p:ph type="sldImg" idx="2"/>
-          </p:nvPr>
-        </p:nvSpPr>
-        <p:spPr>
-          <a:xfrm>
-            <a:off x="381000" y="685800"/>
-            <a:ext cx="6096000" cy="3429000"/>
-          </a:xfrm>
-          <a:custGeom>
-            <a:avLst/>
-            <a:gdLst/>
-            <a:ahLst/>
-            <a:cxnLst/>
-            <a:rect l="l" t="t" r="r" b="b"/>
-            <a:pathLst>
-              <a:path w="120000" h="120000" extrusionOk="0">
-                <a:moveTo>
-                  <a:pt x="0" y="0"/>
-                </a:moveTo>
-                <a:lnTo>
-                  <a:pt x="120000" y="0"/>
-                </a:lnTo>
-                <a:lnTo>
-                  <a:pt x="120000" y="120000"/>
-                </a:lnTo>
-                <a:lnTo>
-                  <a:pt x="0" y="120000"/>
-                </a:lnTo>
-                <a:close/>
-              </a:path>
-            </a:pathLst>
-          </a:custGeom>
-        </p:spPr>
-      </p:sp>
-    </p:spTree>
-  </p:cSld>
-  <p:clrMapOvr>
-    <a:masterClrMapping/>
-  </p:clrMapOvr>
-</p:notes>
-</file>
-
-<file path=ppt/notesSlides/notesSlide2.xml><?xml version="1.0" encoding="utf-8"?>
-<p:notes xmlns:a="http://schemas.openxmlformats.org/drawingml/2006/main" xmlns:r="http://schemas.openxmlformats.org/officeDocument/2006/relationships" xmlns:p="http://schemas.openxmlformats.org/presentationml/2006/main" showMasterSp="0" showMasterPhAnim="0">
-  <p:cSld>
-    <p:spTree>
-      <p:nvGrpSpPr>
-        <p:cNvPr id="1" name="Shape 423"/>
-        <p:cNvGrpSpPr/>
-        <p:nvPr/>
-      </p:nvGrpSpPr>
-      <p:grpSpPr>
-        <a:xfrm>
-          <a:off x="0" y="0"/>
-          <a:ext cx="0" cy="0"/>
-          <a:chOff x="0" y="0"/>
-          <a:chExt cx="0" cy="0"/>
-        </a:xfrm>
-      </p:grpSpPr>
-      <p:sp>
-        <p:nvSpPr>
-          <p:cNvPr id="424" name="Google Shape;424;p22:notes"/>
-          <p:cNvSpPr txBox="1">
-            <a:spLocks noGrp="1"/>
-          </p:cNvSpPr>
-          <p:nvPr>
-            <p:ph type="body" idx="1"/>
-          </p:nvPr>
-        </p:nvSpPr>
-        <p:spPr>
-          <a:xfrm>
-            <a:off x="685800" y="4343400"/>
-            <a:ext cx="5486400" cy="4114800"/>
-          </a:xfrm>
-          <a:prstGeom prst="rect">
-            <a:avLst/>
-          </a:prstGeom>
-        </p:spPr>
-        <p:txBody>
-          <a:bodyPr spcFirstLastPara="1" wrap="square" lIns="91425" tIns="91425" rIns="91425" bIns="91425" anchor="t" anchorCtr="0">
-            <a:noAutofit/>
-          </a:bodyPr>
-          <a:lstStyle/>
-          <a:p>
-            <a:pPr marL="0" lvl="0" indent="0" algn="l" rtl="0">
-              <a:spcBef>
-                <a:spcPts val="0"/>
-              </a:spcBef>
-              <a:spcAft>
-                <a:spcPts val="0"/>
-              </a:spcAft>
-              <a:buNone/>
-            </a:pPr>
-            <a:endParaRPr/>
-          </a:p>
-        </p:txBody>
-      </p:sp>
-      <p:sp>
-        <p:nvSpPr>
-          <p:cNvPr id="425" name="Google Shape;425;p22:notes"/>
           <p:cNvSpPr>
             <a:spLocks noGrp="1" noRot="1" noChangeAspect="1"/>
           </p:cNvSpPr>
@@ -11010,592 +10901,6 @@
 </p:sld>
 </file>
 
-<file path=ppt/slides/slide2.xml><?xml version="1.0" encoding="utf-8"?>
-<p:sld xmlns:a="http://schemas.openxmlformats.org/drawingml/2006/main" xmlns:r="http://schemas.openxmlformats.org/officeDocument/2006/relationships" xmlns:p="http://schemas.openxmlformats.org/presentationml/2006/main">
-  <p:cSld>
-    <p:bg>
-      <p:bgPr>
-        <a:solidFill>
-          <a:srgbClr val="F6E7D8"/>
-        </a:solidFill>
-        <a:effectLst/>
-      </p:bgPr>
-    </p:bg>
-    <p:spTree>
-      <p:nvGrpSpPr>
-        <p:cNvPr id="1" name="Shape 426"/>
-        <p:cNvGrpSpPr/>
-        <p:nvPr/>
-      </p:nvGrpSpPr>
-      <p:grpSpPr>
-        <a:xfrm>
-          <a:off x="0" y="0"/>
-          <a:ext cx="0" cy="0"/>
-          <a:chOff x="0" y="0"/>
-          <a:chExt cx="0" cy="0"/>
-        </a:xfrm>
-      </p:grpSpPr>
-      <p:sp>
-        <p:nvSpPr>
-          <p:cNvPr id="427" name="Google Shape;427;p34"/>
-          <p:cNvSpPr/>
-          <p:nvPr/>
-        </p:nvSpPr>
-        <p:spPr>
-          <a:xfrm rot="-5400000">
-            <a:off x="8033093" y="-26314"/>
-            <a:ext cx="11294409" cy="11282745"/>
-          </a:xfrm>
-          <a:custGeom>
-            <a:avLst/>
-            <a:gdLst/>
-            <a:ahLst/>
-            <a:cxnLst/>
-            <a:rect l="l" t="t" r="r" b="b"/>
-            <a:pathLst>
-              <a:path w="11294409" h="11294409" extrusionOk="0">
-                <a:moveTo>
-                  <a:pt x="0" y="0"/>
-                </a:moveTo>
-                <a:lnTo>
-                  <a:pt x="11294409" y="0"/>
-                </a:lnTo>
-                <a:lnTo>
-                  <a:pt x="11294409" y="11294409"/>
-                </a:lnTo>
-                <a:lnTo>
-                  <a:pt x="0" y="11294409"/>
-                </a:lnTo>
-                <a:lnTo>
-                  <a:pt x="0" y="0"/>
-                </a:lnTo>
-                <a:close/>
-              </a:path>
-            </a:pathLst>
-          </a:custGeom>
-          <a:blipFill rotWithShape="1">
-            <a:blip r:embed="rId3">
-              <a:alphaModFix/>
-            </a:blip>
-            <a:stretch>
-              <a:fillRect/>
-            </a:stretch>
-          </a:blipFill>
-          <a:ln>
-            <a:noFill/>
-          </a:ln>
-        </p:spPr>
-      </p:sp>
-      <p:sp>
-        <p:nvSpPr>
-          <p:cNvPr id="428" name="Google Shape;428;p34"/>
-          <p:cNvSpPr/>
-          <p:nvPr/>
-        </p:nvSpPr>
-        <p:spPr>
-          <a:xfrm rot="5400000">
-            <a:off x="-2432630" y="-32143"/>
-            <a:ext cx="11294409" cy="11294409"/>
-          </a:xfrm>
-          <a:custGeom>
-            <a:avLst/>
-            <a:gdLst/>
-            <a:ahLst/>
-            <a:cxnLst/>
-            <a:rect l="l" t="t" r="r" b="b"/>
-            <a:pathLst>
-              <a:path w="11294409" h="11294409" extrusionOk="0">
-                <a:moveTo>
-                  <a:pt x="11294409" y="11294409"/>
-                </a:moveTo>
-                <a:lnTo>
-                  <a:pt x="0" y="11294409"/>
-                </a:lnTo>
-                <a:lnTo>
-                  <a:pt x="0" y="0"/>
-                </a:lnTo>
-                <a:lnTo>
-                  <a:pt x="11294409" y="0"/>
-                </a:lnTo>
-                <a:lnTo>
-                  <a:pt x="11294409" y="11294409"/>
-                </a:lnTo>
-                <a:close/>
-              </a:path>
-            </a:pathLst>
-          </a:custGeom>
-          <a:blipFill rotWithShape="1">
-            <a:blip r:embed="rId3">
-              <a:alphaModFix/>
-            </a:blip>
-            <a:stretch>
-              <a:fillRect/>
-            </a:stretch>
-          </a:blipFill>
-          <a:ln>
-            <a:noFill/>
-          </a:ln>
-        </p:spPr>
-      </p:sp>
-      <p:grpSp>
-        <p:nvGrpSpPr>
-          <p:cNvPr id="430" name="Google Shape;430;p34"/>
-          <p:cNvGrpSpPr/>
-          <p:nvPr/>
-        </p:nvGrpSpPr>
-        <p:grpSpPr>
-          <a:xfrm>
-            <a:off x="14630402" y="6545577"/>
-            <a:ext cx="4693973" cy="4725652"/>
-            <a:chOff x="-69857" y="-78034"/>
-            <a:chExt cx="809173" cy="814634"/>
-          </a:xfrm>
-        </p:grpSpPr>
-        <p:sp>
-          <p:nvSpPr>
-            <p:cNvPr id="431" name="Google Shape;431;p34"/>
-            <p:cNvSpPr/>
-            <p:nvPr/>
-          </p:nvSpPr>
-          <p:spPr>
-            <a:xfrm>
-              <a:off x="-69857" y="-78034"/>
-              <a:ext cx="809173" cy="812800"/>
-            </a:xfrm>
-            <a:custGeom>
-              <a:avLst/>
-              <a:gdLst/>
-              <a:ahLst/>
-              <a:cxnLst/>
-              <a:rect l="l" t="t" r="r" b="b"/>
-              <a:pathLst>
-                <a:path w="809173" h="812800" extrusionOk="0">
-                  <a:moveTo>
-                    <a:pt x="404587" y="0"/>
-                  </a:moveTo>
-                  <a:cubicBezTo>
-                    <a:pt x="628326" y="1001"/>
-                    <a:pt x="809174" y="182659"/>
-                    <a:pt x="809174" y="406400"/>
-                  </a:cubicBezTo>
-                  <a:cubicBezTo>
-                    <a:pt x="809174" y="630141"/>
-                    <a:pt x="628326" y="811799"/>
-                    <a:pt x="404587" y="812800"/>
-                  </a:cubicBezTo>
-                  <a:cubicBezTo>
-                    <a:pt x="180848" y="811799"/>
-                    <a:pt x="0" y="630141"/>
-                    <a:pt x="0" y="406400"/>
-                  </a:cubicBezTo>
-                  <a:cubicBezTo>
-                    <a:pt x="0" y="182659"/>
-                    <a:pt x="180848" y="1001"/>
-                    <a:pt x="404587" y="0"/>
-                  </a:cubicBezTo>
-                  <a:close/>
-                </a:path>
-              </a:pathLst>
-            </a:custGeom>
-            <a:solidFill>
-              <a:srgbClr val="F4B324"/>
-            </a:solidFill>
-            <a:ln>
-              <a:noFill/>
-            </a:ln>
-          </p:spPr>
-          <p:txBody>
-            <a:bodyPr spcFirstLastPara="1" wrap="square" lIns="91425" tIns="91425" rIns="91425" bIns="91425" anchor="ctr" anchorCtr="0">
-              <a:noAutofit/>
-            </a:bodyPr>
-            <a:lstStyle/>
-            <a:p>
-              <a:pPr marL="0" lvl="0" indent="0" algn="l" rtl="0">
-                <a:spcBef>
-                  <a:spcPts val="0"/>
-                </a:spcBef>
-                <a:spcAft>
-                  <a:spcPts val="0"/>
-                </a:spcAft>
-                <a:buNone/>
-              </a:pPr>
-              <a:endParaRPr/>
-            </a:p>
-          </p:txBody>
-        </p:sp>
-        <p:sp>
-          <p:nvSpPr>
-            <p:cNvPr id="432" name="Google Shape;432;p34"/>
-            <p:cNvSpPr txBox="1"/>
-            <p:nvPr/>
-          </p:nvSpPr>
-          <p:spPr>
-            <a:xfrm>
-              <a:off x="76200" y="38100"/>
-              <a:ext cx="660400" cy="698500"/>
-            </a:xfrm>
-            <a:prstGeom prst="rect">
-              <a:avLst/>
-            </a:prstGeom>
-            <a:noFill/>
-            <a:ln>
-              <a:noFill/>
-            </a:ln>
-          </p:spPr>
-          <p:txBody>
-            <a:bodyPr spcFirstLastPara="1" wrap="square" lIns="50800" tIns="50800" rIns="50800" bIns="50800" anchor="ctr" anchorCtr="0">
-              <a:noAutofit/>
-            </a:bodyPr>
-            <a:lstStyle/>
-            <a:p>
-              <a:pPr marL="0" marR="0" lvl="0" indent="0" algn="ctr" rtl="0">
-                <a:lnSpc>
-                  <a:spcPct val="186611"/>
-                </a:lnSpc>
-                <a:spcBef>
-                  <a:spcPts val="0"/>
-                </a:spcBef>
-                <a:spcAft>
-                  <a:spcPts val="0"/>
-                </a:spcAft>
-                <a:buNone/>
-              </a:pPr>
-              <a:endParaRPr sz="1800" b="0" i="0" u="none" strike="noStrike" cap="none">
-                <a:solidFill>
-                  <a:schemeClr val="dk1"/>
-                </a:solidFill>
-                <a:latin typeface="Calibri"/>
-                <a:ea typeface="Calibri"/>
-                <a:cs typeface="Calibri"/>
-                <a:sym typeface="Calibri"/>
-              </a:endParaRPr>
-            </a:p>
-          </p:txBody>
-        </p:sp>
-      </p:grpSp>
-      <p:sp>
-        <p:nvSpPr>
-          <p:cNvPr id="433" name="Google Shape;433;p34"/>
-          <p:cNvSpPr/>
-          <p:nvPr/>
-        </p:nvSpPr>
-        <p:spPr>
-          <a:xfrm rot="7010750">
-            <a:off x="13284953" y="6175877"/>
-            <a:ext cx="8448498" cy="5632332"/>
-          </a:xfrm>
-          <a:custGeom>
-            <a:avLst/>
-            <a:gdLst/>
-            <a:ahLst/>
-            <a:cxnLst/>
-            <a:rect l="l" t="t" r="r" b="b"/>
-            <a:pathLst>
-              <a:path w="8448498" h="5632332" extrusionOk="0">
-                <a:moveTo>
-                  <a:pt x="0" y="0"/>
-                </a:moveTo>
-                <a:lnTo>
-                  <a:pt x="8448498" y="0"/>
-                </a:lnTo>
-                <a:lnTo>
-                  <a:pt x="8448498" y="5632332"/>
-                </a:lnTo>
-                <a:lnTo>
-                  <a:pt x="0" y="5632332"/>
-                </a:lnTo>
-                <a:lnTo>
-                  <a:pt x="0" y="0"/>
-                </a:lnTo>
-                <a:close/>
-              </a:path>
-            </a:pathLst>
-          </a:custGeom>
-          <a:blipFill rotWithShape="1">
-            <a:blip r:embed="rId4">
-              <a:alphaModFix/>
-            </a:blip>
-            <a:stretch>
-              <a:fillRect/>
-            </a:stretch>
-          </a:blipFill>
-          <a:ln>
-            <a:noFill/>
-          </a:ln>
-        </p:spPr>
-      </p:sp>
-      <p:sp>
-        <p:nvSpPr>
-          <p:cNvPr id="438" name="Google Shape;438;p34"/>
-          <p:cNvSpPr txBox="1"/>
-          <p:nvPr/>
-        </p:nvSpPr>
-        <p:spPr>
-          <a:xfrm>
-            <a:off x="4415522" y="685800"/>
-            <a:ext cx="7726128" cy="1477328"/>
-          </a:xfrm>
-          <a:prstGeom prst="rect">
-            <a:avLst/>
-          </a:prstGeom>
-          <a:noFill/>
-          <a:ln>
-            <a:noFill/>
-          </a:ln>
-        </p:spPr>
-        <p:txBody>
-          <a:bodyPr spcFirstLastPara="1" wrap="square" lIns="0" tIns="0" rIns="0" bIns="0" anchor="t" anchorCtr="0">
-            <a:spAutoFit/>
-          </a:bodyPr>
-          <a:lstStyle/>
-          <a:p>
-            <a:pPr lvl="0" algn="ctr"/>
-            <a:r>
-              <a:rPr lang="en-US" sz="9600" dirty="0" smtClean="0"/>
-              <a:t>{title}</a:t>
-            </a:r>
-            <a:endParaRPr lang="en-US" sz="9600" dirty="0"/>
-          </a:p>
-        </p:txBody>
-      </p:sp>
-      <p:sp>
-        <p:nvSpPr>
-          <p:cNvPr id="439" name="Google Shape;439;p34"/>
-          <p:cNvSpPr txBox="1"/>
-          <p:nvPr/>
-        </p:nvSpPr>
-        <p:spPr>
-          <a:xfrm>
-            <a:off x="3932399" y="2953957"/>
-            <a:ext cx="9084258" cy="1080296"/>
-          </a:xfrm>
-          <a:prstGeom prst="rect">
-            <a:avLst/>
-          </a:prstGeom>
-          <a:noFill/>
-          <a:ln>
-            <a:noFill/>
-          </a:ln>
-        </p:spPr>
-        <p:txBody>
-          <a:bodyPr spcFirstLastPara="1" wrap="square" lIns="0" tIns="0" rIns="0" bIns="0" anchor="t" anchorCtr="0">
-            <a:spAutoFit/>
-          </a:bodyPr>
-          <a:lstStyle/>
-          <a:p>
-            <a:pPr lvl="0" algn="ctr">
-              <a:lnSpc>
-                <a:spcPct val="130000"/>
-              </a:lnSpc>
-            </a:pPr>
-            <a:r>
-              <a:rPr lang="en-US" sz="5400" dirty="0" smtClean="0">
-                <a:solidFill>
-                  <a:schemeClr val="tx1"/>
-                </a:solidFill>
-              </a:rPr>
-              <a:t>{</a:t>
-            </a:r>
-            <a:r>
-              <a:rPr lang="en-US" sz="5400" dirty="0" smtClean="0">
-                <a:solidFill>
-                  <a:schemeClr val="tx1"/>
-                </a:solidFill>
-              </a:rPr>
-              <a:t>bullets}</a:t>
-            </a:r>
-            <a:endParaRPr sz="5400">
-              <a:solidFill>
-                <a:schemeClr val="tx1"/>
-              </a:solidFill>
-            </a:endParaRPr>
-          </a:p>
-        </p:txBody>
-      </p:sp>
-      <p:sp>
-        <p:nvSpPr>
-          <p:cNvPr id="441" name="Google Shape;441;p34"/>
-          <p:cNvSpPr txBox="1"/>
-          <p:nvPr/>
-        </p:nvSpPr>
-        <p:spPr>
-          <a:xfrm>
-            <a:off x="5576014" y="8681612"/>
-            <a:ext cx="7431050" cy="900246"/>
-          </a:xfrm>
-          <a:prstGeom prst="rect">
-            <a:avLst/>
-          </a:prstGeom>
-          <a:noFill/>
-          <a:ln>
-            <a:noFill/>
-          </a:ln>
-        </p:spPr>
-        <p:txBody>
-          <a:bodyPr spcFirstLastPara="1" wrap="square" lIns="0" tIns="0" rIns="0" bIns="0" anchor="t" anchorCtr="0">
-            <a:spAutoFit/>
-          </a:bodyPr>
-          <a:lstStyle/>
-          <a:p>
-            <a:pPr marL="0" marR="0" lvl="0" indent="0" algn="ctr" rtl="0">
-              <a:lnSpc>
-                <a:spcPct val="130000"/>
-              </a:lnSpc>
-              <a:spcBef>
-                <a:spcPts val="0"/>
-              </a:spcBef>
-              <a:spcAft>
-                <a:spcPts val="0"/>
-              </a:spcAft>
-              <a:buNone/>
-            </a:pPr>
-            <a:r>
-              <a:rPr lang="en-US" sz="4500" b="0" i="0" u="none" strike="noStrike" cap="none" dirty="0" smtClean="0">
-                <a:solidFill>
-                  <a:srgbClr val="40C0DF"/>
-                </a:solidFill>
-                <a:latin typeface="Hammersmith One"/>
-                <a:ea typeface="Hammersmith One"/>
-                <a:cs typeface="Hammersmith One"/>
-                <a:sym typeface="Hammersmith One"/>
-              </a:rPr>
-              <a:t> </a:t>
-            </a:r>
-            <a:endParaRPr/>
-          </a:p>
-        </p:txBody>
-      </p:sp>
-      <p:sp>
-        <p:nvSpPr>
-          <p:cNvPr id="19" name="Google Shape;431;p34"/>
-          <p:cNvSpPr/>
-          <p:nvPr/>
-        </p:nvSpPr>
-        <p:spPr>
-          <a:xfrm>
-            <a:off x="-2477613" y="0"/>
-            <a:ext cx="4693973" cy="4715013"/>
-          </a:xfrm>
-          <a:custGeom>
-            <a:avLst/>
-            <a:gdLst/>
-            <a:ahLst/>
-            <a:cxnLst/>
-            <a:rect l="l" t="t" r="r" b="b"/>
-            <a:pathLst>
-              <a:path w="809173" h="812800" extrusionOk="0">
-                <a:moveTo>
-                  <a:pt x="404587" y="0"/>
-                </a:moveTo>
-                <a:cubicBezTo>
-                  <a:pt x="628326" y="1001"/>
-                  <a:pt x="809174" y="182659"/>
-                  <a:pt x="809174" y="406400"/>
-                </a:cubicBezTo>
-                <a:cubicBezTo>
-                  <a:pt x="809174" y="630141"/>
-                  <a:pt x="628326" y="811799"/>
-                  <a:pt x="404587" y="812800"/>
-                </a:cubicBezTo>
-                <a:cubicBezTo>
-                  <a:pt x="180848" y="811799"/>
-                  <a:pt x="0" y="630141"/>
-                  <a:pt x="0" y="406400"/>
-                </a:cubicBezTo>
-                <a:cubicBezTo>
-                  <a:pt x="0" y="182659"/>
-                  <a:pt x="180848" y="1001"/>
-                  <a:pt x="404587" y="0"/>
-                </a:cubicBezTo>
-                <a:close/>
-              </a:path>
-            </a:pathLst>
-          </a:custGeom>
-          <a:solidFill>
-            <a:srgbClr val="F4B324"/>
-          </a:solidFill>
-          <a:ln>
-            <a:noFill/>
-          </a:ln>
-        </p:spPr>
-        <p:txBody>
-          <a:bodyPr spcFirstLastPara="1" wrap="square" lIns="91425" tIns="91425" rIns="91425" bIns="91425" anchor="ctr" anchorCtr="0">
-            <a:noAutofit/>
-          </a:bodyPr>
-          <a:lstStyle/>
-          <a:p>
-            <a:pPr marL="0" lvl="0" indent="0" algn="l" rtl="0">
-              <a:spcBef>
-                <a:spcPts val="0"/>
-              </a:spcBef>
-              <a:spcAft>
-                <a:spcPts val="0"/>
-              </a:spcAft>
-              <a:buNone/>
-            </a:pPr>
-            <a:endParaRPr/>
-          </a:p>
-        </p:txBody>
-      </p:sp>
-      <p:sp>
-        <p:nvSpPr>
-          <p:cNvPr id="20" name="Google Shape;433;p34"/>
-          <p:cNvSpPr/>
-          <p:nvPr/>
-        </p:nvSpPr>
-        <p:spPr>
-          <a:xfrm rot="18429393">
-            <a:off x="-5083403" y="-624391"/>
-            <a:ext cx="8448498" cy="5632332"/>
-          </a:xfrm>
-          <a:custGeom>
-            <a:avLst/>
-            <a:gdLst/>
-            <a:ahLst/>
-            <a:cxnLst/>
-            <a:rect l="l" t="t" r="r" b="b"/>
-            <a:pathLst>
-              <a:path w="8448498" h="5632332" extrusionOk="0">
-                <a:moveTo>
-                  <a:pt x="0" y="0"/>
-                </a:moveTo>
-                <a:lnTo>
-                  <a:pt x="8448498" y="0"/>
-                </a:lnTo>
-                <a:lnTo>
-                  <a:pt x="8448498" y="5632332"/>
-                </a:lnTo>
-                <a:lnTo>
-                  <a:pt x="0" y="5632332"/>
-                </a:lnTo>
-                <a:lnTo>
-                  <a:pt x="0" y="0"/>
-                </a:lnTo>
-                <a:close/>
-              </a:path>
-            </a:pathLst>
-          </a:custGeom>
-          <a:blipFill rotWithShape="1">
-            <a:blip r:embed="rId4">
-              <a:alphaModFix/>
-            </a:blip>
-            <a:stretch>
-              <a:fillRect/>
-            </a:stretch>
-          </a:blipFill>
-          <a:ln>
-            <a:noFill/>
-          </a:ln>
-        </p:spPr>
-      </p:sp>
-    </p:spTree>
-  </p:cSld>
-  <p:clrMapOvr>
-    <a:masterClrMapping/>
-  </p:clrMapOvr>
-</p:sld>
-</file>
-
 <file path=ppt/theme/theme1.xml><?xml version="1.0" encoding="utf-8"?>
 <a:theme xmlns:a="http://schemas.openxmlformats.org/drawingml/2006/main" name="Office Theme">
   <a:themeElements>

</xml_diff>